<commit_message>
Update co-founders slide with richer profiles
Ankit: Product · AI Engineering · Platform. 18+ yrs AI/DT/PM, ex-Director
Program Mgmt at Atos (€35M P&L, 200+ team), M.S. Comp Sci IMT Atlantique,
PMP/Azure/AWS/GCP/CSM.

Deepak: GTM · Sales · Partnerships. 20+ yrs leading data and automation,
ex-McKinsey, ex-PwC, currently Professor of Analytics & AI at a reputed
MBA college.

Nitigya: Brand · Marketing · Social. Personal credentials left as explicit
"[to add]" placeholders — she fills them in.

Layout change: dropped "Built in Delhi" heading, added "Co-Founder"
subtitle under each name, added "Owns:" label line, swapped single bio
paragraph for a 4-bullet credential list.

Co-Authored-By: Claude Opus 4.7 <noreply@anthropic.com>
</commit_message>
<xml_diff>
--- a/Deck-CoachingCentres.pptx
+++ b/Deck-CoachingCentres.pptx
@@ -4316,7 +4316,7 @@
         <p:spPr>
           <a:xfrm>
             <a:off x="548640" y="960120"/>
-            <a:ext cx="11091672" cy="777240"/>
+            <a:ext cx="11091672" cy="548640"/>
           </a:xfrm>
           <a:prstGeom prst="rect">
             <a:avLst/>
@@ -4332,7 +4332,7 @@
               <a:buNone/>
             </a:pPr>
             <a:r>
-              <a:rPr lang="en-US" sz="4000" spc="-100" kern="0" dirty="0">
+              <a:rPr lang="en-US" sz="3000" spc="-50" kern="0" dirty="0">
                 <a:solidFill>
                   <a:srgbClr val="1F0F2A"/>
                 </a:solidFill>
@@ -4340,9 +4340,9 @@
                 <a:ea typeface="Cambria" pitchFamily="34" charset="-122"/>
                 <a:cs typeface="Cambria" pitchFamily="34" charset="-120"/>
               </a:rPr>
-              <a:t>Built in Delhi</a:t>
-            </a:r>
-            <a:endParaRPr lang="en-US" sz="4000" dirty="0"/>
+              <a:t>The team building GyanSaar</a:t>
+            </a:r>
+            <a:endParaRPr lang="en-US" sz="3000" dirty="0"/>
           </a:p>
         </p:txBody>
       </p:sp>
@@ -4354,8 +4354,8 @@
         </p:nvSpPr>
         <p:spPr>
           <a:xfrm>
-            <a:off x="1691640" y="2103120"/>
-            <a:ext cx="1280160" cy="1280160"/>
+            <a:off x="1851660" y="1691640"/>
+            <a:ext cx="960120" cy="960120"/>
           </a:xfrm>
           <a:prstGeom prst="ellipse">
             <a:avLst/>
@@ -4379,8 +4379,8 @@
         </p:nvSpPr>
         <p:spPr>
           <a:xfrm>
-            <a:off x="1691640" y="2103120"/>
-            <a:ext cx="1280160" cy="1280160"/>
+            <a:off x="1851660" y="1691640"/>
+            <a:ext cx="960120" cy="960120"/>
           </a:xfrm>
           <a:prstGeom prst="rect">
             <a:avLst/>
@@ -4396,7 +4396,7 @@
               <a:buNone/>
             </a:pPr>
             <a:r>
-              <a:rPr lang="en-US" sz="6000" dirty="0">
+              <a:rPr lang="en-US" sz="4400" dirty="0">
                 <a:solidFill>
                   <a:srgbClr val="FFFFFF"/>
                 </a:solidFill>
@@ -4406,7 +4406,7 @@
               </a:rPr>
               <a:t>A</a:t>
             </a:r>
-            <a:endParaRPr lang="en-US" sz="6000" dirty="0"/>
+            <a:endParaRPr lang="en-US" sz="4400" dirty="0"/>
           </a:p>
         </p:txBody>
       </p:sp>
@@ -4418,8 +4418,8 @@
         </p:nvSpPr>
         <p:spPr>
           <a:xfrm>
-            <a:off x="548640" y="3566160"/>
-            <a:ext cx="3566160" cy="457200"/>
+            <a:off x="548640" y="2788920"/>
+            <a:ext cx="3566160" cy="411480"/>
           </a:xfrm>
           <a:prstGeom prst="rect">
             <a:avLst/>
@@ -4457,7 +4457,7 @@
         </p:nvSpPr>
         <p:spPr>
           <a:xfrm>
-            <a:off x="548640" y="4023360"/>
+            <a:off x="548640" y="3182112"/>
             <a:ext cx="3566160" cy="274320"/>
           </a:xfrm>
           <a:prstGeom prst="rect">
@@ -4474,7 +4474,46 @@
               <a:buNone/>
             </a:pPr>
             <a:r>
-              <a:rPr lang="en-US" sz="1000" b="1" spc="400" kern="0" dirty="0">
+              <a:rPr lang="en-US" sz="1300" i="1" dirty="0">
+                <a:solidFill>
+                  <a:srgbClr val="8D82A0"/>
+                </a:solidFill>
+                <a:latin typeface="Cambria" pitchFamily="34" charset="0"/>
+                <a:ea typeface="Cambria" pitchFamily="34" charset="-122"/>
+                <a:cs typeface="Cambria" pitchFamily="34" charset="-120"/>
+              </a:rPr>
+              <a:t>Co-Founder</a:t>
+            </a:r>
+            <a:endParaRPr lang="en-US" sz="1300" dirty="0"/>
+          </a:p>
+        </p:txBody>
+      </p:sp>
+      <p:sp>
+        <p:nvSpPr>
+          <p:cNvPr id="8" name="Text 6"/>
+          <p:cNvSpPr txBox="1"/>
+          <p:nvPr/>
+        </p:nvSpPr>
+        <p:spPr>
+          <a:xfrm>
+            <a:off x="640080" y="3520440"/>
+            <a:ext cx="3383280" cy="320040"/>
+          </a:xfrm>
+          <a:prstGeom prst="rect">
+            <a:avLst/>
+          </a:prstGeom>
+          <a:noFill/>
+          <a:ln/>
+        </p:spPr>
+        <p:txBody>
+          <a:bodyPr wrap="square" lIns="0" tIns="0" rIns="0" bIns="0" rtlCol="0" anchor="ctr"/>
+          <a:lstStyle/>
+          <a:p>
+            <a:pPr algn="ctr" indent="0" marL="0">
+              <a:buNone/>
+            </a:pPr>
+            <a:r>
+              <a:rPr lang="en-US" sz="1100" b="1" dirty="0">
                 <a:solidFill>
                   <a:srgbClr val="A83787"/>
                 </a:solidFill>
@@ -4482,48 +4521,23 @@
                 <a:ea typeface="Calibri" pitchFamily="34" charset="-122"/>
                 <a:cs typeface="Calibri" pitchFamily="34" charset="-120"/>
               </a:rPr>
-              <a:t>BUILD &amp; ENGINEERING</a:t>
-            </a:r>
-            <a:endParaRPr lang="en-US" sz="1000" dirty="0"/>
-          </a:p>
-        </p:txBody>
-      </p:sp>
-      <p:sp>
-        <p:nvSpPr>
-          <p:cNvPr id="8" name="Text 6"/>
-          <p:cNvSpPr txBox="1"/>
-          <p:nvPr/>
-        </p:nvSpPr>
-        <p:spPr>
-          <a:xfrm>
-            <a:off x="640080" y="4434840"/>
-            <a:ext cx="3383280" cy="1463040"/>
-          </a:xfrm>
-          <a:prstGeom prst="rect">
-            <a:avLst/>
-          </a:prstGeom>
-          <a:noFill/>
-          <a:ln/>
-        </p:spPr>
-        <p:txBody>
-          <a:bodyPr wrap="square" lIns="0" tIns="0" rIns="0" bIns="0" rtlCol="0" anchor="t"/>
-          <a:lstStyle/>
-          <a:p>
+              <a:t>Owns: </a:t>
+            </a:r>
             <a:pPr algn="ctr" indent="0" marL="0">
               <a:buNone/>
             </a:pPr>
             <a:r>
-              <a:rPr lang="en-US" sz="1200" dirty="0">
-                <a:solidFill>
-                  <a:srgbClr val="3D3247"/>
+              <a:rPr lang="en-US" sz="1100" dirty="0">
+                <a:solidFill>
+                  <a:srgbClr val="1F0F2A"/>
                 </a:solidFill>
                 <a:latin typeface="Calibri" pitchFamily="34" charset="0"/>
                 <a:ea typeface="Calibri" pitchFamily="34" charset="-122"/>
                 <a:cs typeface="Calibri" pitchFamily="34" charset="-120"/>
               </a:rPr>
-              <a:t>Owns engineering across every module — the recording engine, LMS, WhatsApp bot, and admin portal. Sets the technical direction for the company.</a:t>
-            </a:r>
-            <a:endParaRPr lang="en-US" sz="1200" dirty="0"/>
+              <a:t>Product · AI Engineering · Platform</a:t>
+            </a:r>
+            <a:endParaRPr lang="en-US" sz="1100" dirty="0"/>
           </a:p>
         </p:txBody>
       </p:sp>
@@ -4535,8 +4549,264 @@
         </p:nvSpPr>
         <p:spPr>
           <a:xfrm>
-            <a:off x="5458968" y="2103120"/>
-            <a:ext cx="1280160" cy="1280160"/>
+            <a:off x="640080" y="4105656"/>
+            <a:ext cx="91440" cy="91440"/>
+          </a:xfrm>
+          <a:prstGeom prst="ellipse">
+            <a:avLst/>
+          </a:prstGeom>
+          <a:solidFill>
+            <a:srgbClr val="A83787"/>
+          </a:solidFill>
+          <a:ln w="12700">
+            <a:solidFill>
+              <a:srgbClr val="A83787"/>
+            </a:solidFill>
+            <a:prstDash val="solid"/>
+          </a:ln>
+        </p:spPr>
+      </p:sp>
+      <p:sp>
+        <p:nvSpPr>
+          <p:cNvPr id="10" name="Text 8"/>
+          <p:cNvSpPr txBox="1"/>
+          <p:nvPr/>
+        </p:nvSpPr>
+        <p:spPr>
+          <a:xfrm>
+            <a:off x="822960" y="3977640"/>
+            <a:ext cx="3246120" cy="502920"/>
+          </a:xfrm>
+          <a:prstGeom prst="rect">
+            <a:avLst/>
+          </a:prstGeom>
+          <a:noFill/>
+          <a:ln/>
+        </p:spPr>
+        <p:txBody>
+          <a:bodyPr wrap="square" lIns="0" tIns="0" rIns="0" bIns="0" rtlCol="0" anchor="t"/>
+          <a:lstStyle/>
+          <a:p>
+            <a:pPr indent="0" marL="0">
+              <a:buNone/>
+            </a:pPr>
+            <a:r>
+              <a:rPr lang="en-US" sz="1100" dirty="0">
+                <a:solidFill>
+                  <a:srgbClr val="3D3247"/>
+                </a:solidFill>
+                <a:latin typeface="Calibri" pitchFamily="34" charset="0"/>
+                <a:ea typeface="Calibri" pitchFamily="34" charset="-122"/>
+                <a:cs typeface="Calibri" pitchFamily="34" charset="-120"/>
+              </a:rPr>
+              <a:t>18+ yrs in AI, Digital Transformation &amp; Program Mgmt</a:t>
+            </a:r>
+            <a:endParaRPr lang="en-US" sz="1100" dirty="0"/>
+          </a:p>
+        </p:txBody>
+      </p:sp>
+      <p:sp>
+        <p:nvSpPr>
+          <p:cNvPr id="11" name="Shape 9"/>
+          <p:cNvSpPr/>
+          <p:nvPr/>
+        </p:nvSpPr>
+        <p:spPr>
+          <a:xfrm>
+            <a:off x="640080" y="4608576"/>
+            <a:ext cx="91440" cy="91440"/>
+          </a:xfrm>
+          <a:prstGeom prst="ellipse">
+            <a:avLst/>
+          </a:prstGeom>
+          <a:solidFill>
+            <a:srgbClr val="A83787"/>
+          </a:solidFill>
+          <a:ln w="12700">
+            <a:solidFill>
+              <a:srgbClr val="A83787"/>
+            </a:solidFill>
+            <a:prstDash val="solid"/>
+          </a:ln>
+        </p:spPr>
+      </p:sp>
+      <p:sp>
+        <p:nvSpPr>
+          <p:cNvPr id="12" name="Text 10"/>
+          <p:cNvSpPr txBox="1"/>
+          <p:nvPr/>
+        </p:nvSpPr>
+        <p:spPr>
+          <a:xfrm>
+            <a:off x="822960" y="4480560"/>
+            <a:ext cx="3246120" cy="502920"/>
+          </a:xfrm>
+          <a:prstGeom prst="rect">
+            <a:avLst/>
+          </a:prstGeom>
+          <a:noFill/>
+          <a:ln/>
+        </p:spPr>
+        <p:txBody>
+          <a:bodyPr wrap="square" lIns="0" tIns="0" rIns="0" bIns="0" rtlCol="0" anchor="t"/>
+          <a:lstStyle/>
+          <a:p>
+            <a:pPr indent="0" marL="0">
+              <a:buNone/>
+            </a:pPr>
+            <a:r>
+              <a:rPr lang="en-US" sz="1100" dirty="0">
+                <a:solidFill>
+                  <a:srgbClr val="3D3247"/>
+                </a:solidFill>
+                <a:latin typeface="Calibri" pitchFamily="34" charset="0"/>
+                <a:ea typeface="Calibri" pitchFamily="34" charset="-122"/>
+                <a:cs typeface="Calibri" pitchFamily="34" charset="-120"/>
+              </a:rPr>
+              <a:t>Director — Program Mgmt, Atos — €35M P&amp;L, 200+ team</a:t>
+            </a:r>
+            <a:endParaRPr lang="en-US" sz="1100" dirty="0"/>
+          </a:p>
+        </p:txBody>
+      </p:sp>
+      <p:sp>
+        <p:nvSpPr>
+          <p:cNvPr id="13" name="Shape 11"/>
+          <p:cNvSpPr/>
+          <p:nvPr/>
+        </p:nvSpPr>
+        <p:spPr>
+          <a:xfrm>
+            <a:off x="640080" y="5111496"/>
+            <a:ext cx="91440" cy="91440"/>
+          </a:xfrm>
+          <a:prstGeom prst="ellipse">
+            <a:avLst/>
+          </a:prstGeom>
+          <a:solidFill>
+            <a:srgbClr val="A83787"/>
+          </a:solidFill>
+          <a:ln w="12700">
+            <a:solidFill>
+              <a:srgbClr val="A83787"/>
+            </a:solidFill>
+            <a:prstDash val="solid"/>
+          </a:ln>
+        </p:spPr>
+      </p:sp>
+      <p:sp>
+        <p:nvSpPr>
+          <p:cNvPr id="14" name="Text 12"/>
+          <p:cNvSpPr txBox="1"/>
+          <p:nvPr/>
+        </p:nvSpPr>
+        <p:spPr>
+          <a:xfrm>
+            <a:off x="822960" y="4983480"/>
+            <a:ext cx="3246120" cy="502920"/>
+          </a:xfrm>
+          <a:prstGeom prst="rect">
+            <a:avLst/>
+          </a:prstGeom>
+          <a:noFill/>
+          <a:ln/>
+        </p:spPr>
+        <p:txBody>
+          <a:bodyPr wrap="square" lIns="0" tIns="0" rIns="0" bIns="0" rtlCol="0" anchor="t"/>
+          <a:lstStyle/>
+          <a:p>
+            <a:pPr indent="0" marL="0">
+              <a:buNone/>
+            </a:pPr>
+            <a:r>
+              <a:rPr lang="en-US" sz="1100" dirty="0">
+                <a:solidFill>
+                  <a:srgbClr val="3D3247"/>
+                </a:solidFill>
+                <a:latin typeface="Calibri" pitchFamily="34" charset="0"/>
+                <a:ea typeface="Calibri" pitchFamily="34" charset="-122"/>
+                <a:cs typeface="Calibri" pitchFamily="34" charset="-120"/>
+              </a:rPr>
+              <a:t>M.S. Computer Science — IMT Atlantique, France</a:t>
+            </a:r>
+            <a:endParaRPr lang="en-US" sz="1100" dirty="0"/>
+          </a:p>
+        </p:txBody>
+      </p:sp>
+      <p:sp>
+        <p:nvSpPr>
+          <p:cNvPr id="15" name="Shape 13"/>
+          <p:cNvSpPr/>
+          <p:nvPr/>
+        </p:nvSpPr>
+        <p:spPr>
+          <a:xfrm>
+            <a:off x="640080" y="5614416"/>
+            <a:ext cx="91440" cy="91440"/>
+          </a:xfrm>
+          <a:prstGeom prst="ellipse">
+            <a:avLst/>
+          </a:prstGeom>
+          <a:solidFill>
+            <a:srgbClr val="A83787"/>
+          </a:solidFill>
+          <a:ln w="12700">
+            <a:solidFill>
+              <a:srgbClr val="A83787"/>
+            </a:solidFill>
+            <a:prstDash val="solid"/>
+          </a:ln>
+        </p:spPr>
+      </p:sp>
+      <p:sp>
+        <p:nvSpPr>
+          <p:cNvPr id="16" name="Text 14"/>
+          <p:cNvSpPr txBox="1"/>
+          <p:nvPr/>
+        </p:nvSpPr>
+        <p:spPr>
+          <a:xfrm>
+            <a:off x="822960" y="5486400"/>
+            <a:ext cx="3246120" cy="502920"/>
+          </a:xfrm>
+          <a:prstGeom prst="rect">
+            <a:avLst/>
+          </a:prstGeom>
+          <a:noFill/>
+          <a:ln/>
+        </p:spPr>
+        <p:txBody>
+          <a:bodyPr wrap="square" lIns="0" tIns="0" rIns="0" bIns="0" rtlCol="0" anchor="t"/>
+          <a:lstStyle/>
+          <a:p>
+            <a:pPr indent="0" marL="0">
+              <a:buNone/>
+            </a:pPr>
+            <a:r>
+              <a:rPr lang="en-US" sz="1100" dirty="0">
+                <a:solidFill>
+                  <a:srgbClr val="3D3247"/>
+                </a:solidFill>
+                <a:latin typeface="Calibri" pitchFamily="34" charset="0"/>
+                <a:ea typeface="Calibri" pitchFamily="34" charset="-122"/>
+                <a:cs typeface="Calibri" pitchFamily="34" charset="-120"/>
+              </a:rPr>
+              <a:t>PMP · Azure · AWS · GCP · CSM</a:t>
+            </a:r>
+            <a:endParaRPr lang="en-US" sz="1100" dirty="0"/>
+          </a:p>
+        </p:txBody>
+      </p:sp>
+      <p:sp>
+        <p:nvSpPr>
+          <p:cNvPr id="17" name="Shape 15"/>
+          <p:cNvSpPr/>
+          <p:nvPr/>
+        </p:nvSpPr>
+        <p:spPr>
+          <a:xfrm>
+            <a:off x="5618988" y="1691640"/>
+            <a:ext cx="960120" cy="960120"/>
           </a:xfrm>
           <a:prstGeom prst="ellipse">
             <a:avLst/>
@@ -4554,14 +4824,14 @@
       </p:sp>
       <p:sp>
         <p:nvSpPr>
-          <p:cNvPr id="10" name="Text 8"/>
-          <p:cNvSpPr txBox="1"/>
-          <p:nvPr/>
-        </p:nvSpPr>
-        <p:spPr>
-          <a:xfrm>
-            <a:off x="5458968" y="2103120"/>
-            <a:ext cx="1280160" cy="1280160"/>
+          <p:cNvPr id="18" name="Text 16"/>
+          <p:cNvSpPr txBox="1"/>
+          <p:nvPr/>
+        </p:nvSpPr>
+        <p:spPr>
+          <a:xfrm>
+            <a:off x="5618988" y="1691640"/>
+            <a:ext cx="960120" cy="960120"/>
           </a:xfrm>
           <a:prstGeom prst="rect">
             <a:avLst/>
@@ -4577,7 +4847,7 @@
               <a:buNone/>
             </a:pPr>
             <a:r>
-              <a:rPr lang="en-US" sz="6000" dirty="0">
+              <a:rPr lang="en-US" sz="4400" dirty="0">
                 <a:solidFill>
                   <a:srgbClr val="FFFFFF"/>
                 </a:solidFill>
@@ -4587,20 +4857,20 @@
               </a:rPr>
               <a:t>N</a:t>
             </a:r>
-            <a:endParaRPr lang="en-US" sz="6000" dirty="0"/>
-          </a:p>
-        </p:txBody>
-      </p:sp>
-      <p:sp>
-        <p:nvSpPr>
-          <p:cNvPr id="11" name="Text 9"/>
-          <p:cNvSpPr txBox="1"/>
-          <p:nvPr/>
-        </p:nvSpPr>
-        <p:spPr>
-          <a:xfrm>
-            <a:off x="4315968" y="3566160"/>
-            <a:ext cx="3566160" cy="457200"/>
+            <a:endParaRPr lang="en-US" sz="4400" dirty="0"/>
+          </a:p>
+        </p:txBody>
+      </p:sp>
+      <p:sp>
+        <p:nvSpPr>
+          <p:cNvPr id="19" name="Text 17"/>
+          <p:cNvSpPr txBox="1"/>
+          <p:nvPr/>
+        </p:nvSpPr>
+        <p:spPr>
+          <a:xfrm>
+            <a:off x="4315968" y="2788920"/>
+            <a:ext cx="3566160" cy="411480"/>
           </a:xfrm>
           <a:prstGeom prst="rect">
             <a:avLst/>
@@ -4632,13 +4902,13 @@
       </p:sp>
       <p:sp>
         <p:nvSpPr>
-          <p:cNvPr id="12" name="Text 10"/>
-          <p:cNvSpPr txBox="1"/>
-          <p:nvPr/>
-        </p:nvSpPr>
-        <p:spPr>
-          <a:xfrm>
-            <a:off x="4315968" y="4023360"/>
+          <p:cNvPr id="20" name="Text 18"/>
+          <p:cNvSpPr txBox="1"/>
+          <p:nvPr/>
+        </p:nvSpPr>
+        <p:spPr>
+          <a:xfrm>
+            <a:off x="4315968" y="3182112"/>
             <a:ext cx="3566160" cy="274320"/>
           </a:xfrm>
           <a:prstGeom prst="rect">
@@ -4655,7 +4925,46 @@
               <a:buNone/>
             </a:pPr>
             <a:r>
-              <a:rPr lang="en-US" sz="1000" b="1" spc="400" kern="0" dirty="0">
+              <a:rPr lang="en-US" sz="1300" i="1" dirty="0">
+                <a:solidFill>
+                  <a:srgbClr val="8D82A0"/>
+                </a:solidFill>
+                <a:latin typeface="Cambria" pitchFamily="34" charset="0"/>
+                <a:ea typeface="Cambria" pitchFamily="34" charset="-122"/>
+                <a:cs typeface="Cambria" pitchFamily="34" charset="-120"/>
+              </a:rPr>
+              <a:t>Co-Founder</a:t>
+            </a:r>
+            <a:endParaRPr lang="en-US" sz="1300" dirty="0"/>
+          </a:p>
+        </p:txBody>
+      </p:sp>
+      <p:sp>
+        <p:nvSpPr>
+          <p:cNvPr id="21" name="Text 19"/>
+          <p:cNvSpPr txBox="1"/>
+          <p:nvPr/>
+        </p:nvSpPr>
+        <p:spPr>
+          <a:xfrm>
+            <a:off x="4407408" y="3520440"/>
+            <a:ext cx="3383280" cy="320040"/>
+          </a:xfrm>
+          <a:prstGeom prst="rect">
+            <a:avLst/>
+          </a:prstGeom>
+          <a:noFill/>
+          <a:ln/>
+        </p:spPr>
+        <p:txBody>
+          <a:bodyPr wrap="square" lIns="0" tIns="0" rIns="0" bIns="0" rtlCol="0" anchor="ctr"/>
+          <a:lstStyle/>
+          <a:p>
+            <a:pPr algn="ctr" indent="0" marL="0">
+              <a:buNone/>
+            </a:pPr>
+            <a:r>
+              <a:rPr lang="en-US" sz="1100" b="1" dirty="0">
                 <a:solidFill>
                   <a:srgbClr val="A83787"/>
                 </a:solidFill>
@@ -4663,61 +4972,292 @@
                 <a:ea typeface="Calibri" pitchFamily="34" charset="-122"/>
                 <a:cs typeface="Calibri" pitchFamily="34" charset="-120"/>
               </a:rPr>
-              <a:t>BRAND &amp; MARKETING</a:t>
-            </a:r>
-            <a:endParaRPr lang="en-US" sz="1000" dirty="0"/>
-          </a:p>
-        </p:txBody>
-      </p:sp>
-      <p:sp>
-        <p:nvSpPr>
-          <p:cNvPr id="13" name="Text 11"/>
-          <p:cNvSpPr txBox="1"/>
-          <p:nvPr/>
-        </p:nvSpPr>
-        <p:spPr>
-          <a:xfrm>
-            <a:off x="4407408" y="4434840"/>
-            <a:ext cx="3383280" cy="1463040"/>
-          </a:xfrm>
-          <a:prstGeom prst="rect">
-            <a:avLst/>
-          </a:prstGeom>
-          <a:noFill/>
-          <a:ln/>
-        </p:spPr>
-        <p:txBody>
-          <a:bodyPr wrap="square" lIns="0" tIns="0" rIns="0" bIns="0" rtlCol="0" anchor="t"/>
-          <a:lstStyle/>
-          <a:p>
+              <a:t>Owns: </a:t>
+            </a:r>
             <a:pPr algn="ctr" indent="0" marL="0">
               <a:buNone/>
             </a:pPr>
             <a:r>
-              <a:rPr lang="en-US" sz="1200" dirty="0">
-                <a:solidFill>
-                  <a:srgbClr val="3D3247"/>
+              <a:rPr lang="en-US" sz="1100" dirty="0">
+                <a:solidFill>
+                  <a:srgbClr val="1F0F2A"/>
                 </a:solidFill>
                 <a:latin typeface="Calibri" pitchFamily="34" charset="0"/>
                 <a:ea typeface="Calibri" pitchFamily="34" charset="-122"/>
                 <a:cs typeface="Calibri" pitchFamily="34" charset="-120"/>
               </a:rPr>
-              <a:t>Owns brand and social presence. Runs the marketing website, the Instagram cadence, and holds product surface polish to a consistent standard.</a:t>
-            </a:r>
-            <a:endParaRPr lang="en-US" sz="1200" dirty="0"/>
-          </a:p>
-        </p:txBody>
-      </p:sp>
-      <p:sp>
-        <p:nvSpPr>
-          <p:cNvPr id="14" name="Shape 12"/>
+              <a:t>Brand · Marketing · Social</a:t>
+            </a:r>
+            <a:endParaRPr lang="en-US" sz="1100" dirty="0"/>
+          </a:p>
+        </p:txBody>
+      </p:sp>
+      <p:sp>
+        <p:nvSpPr>
+          <p:cNvPr id="22" name="Shape 20"/>
           <p:cNvSpPr/>
           <p:nvPr/>
         </p:nvSpPr>
         <p:spPr>
           <a:xfrm>
-            <a:off x="9226296" y="2103120"/>
-            <a:ext cx="1280160" cy="1280160"/>
+            <a:off x="4407408" y="4105656"/>
+            <a:ext cx="91440" cy="91440"/>
+          </a:xfrm>
+          <a:prstGeom prst="ellipse">
+            <a:avLst/>
+          </a:prstGeom>
+          <a:solidFill>
+            <a:srgbClr val="A83787"/>
+          </a:solidFill>
+          <a:ln w="12700">
+            <a:solidFill>
+              <a:srgbClr val="A83787"/>
+            </a:solidFill>
+            <a:prstDash val="solid"/>
+          </a:ln>
+        </p:spPr>
+      </p:sp>
+      <p:sp>
+        <p:nvSpPr>
+          <p:cNvPr id="23" name="Text 21"/>
+          <p:cNvSpPr txBox="1"/>
+          <p:nvPr/>
+        </p:nvSpPr>
+        <p:spPr>
+          <a:xfrm>
+            <a:off x="4590288" y="3977640"/>
+            <a:ext cx="3246120" cy="502920"/>
+          </a:xfrm>
+          <a:prstGeom prst="rect">
+            <a:avLst/>
+          </a:prstGeom>
+          <a:noFill/>
+          <a:ln/>
+        </p:spPr>
+        <p:txBody>
+          <a:bodyPr wrap="square" lIns="0" tIns="0" rIns="0" bIns="0" rtlCol="0" anchor="t"/>
+          <a:lstStyle/>
+          <a:p>
+            <a:pPr indent="0" marL="0">
+              <a:buNone/>
+            </a:pPr>
+            <a:r>
+              <a:rPr lang="en-US" sz="1100" dirty="0">
+                <a:solidFill>
+                  <a:srgbClr val="3D3247"/>
+                </a:solidFill>
+                <a:latin typeface="Calibri" pitchFamily="34" charset="0"/>
+                <a:ea typeface="Calibri" pitchFamily="34" charset="-122"/>
+                <a:cs typeface="Calibri" pitchFamily="34" charset="-120"/>
+              </a:rPr>
+              <a:t>[Years of experience — to add]</a:t>
+            </a:r>
+            <a:endParaRPr lang="en-US" sz="1100" dirty="0"/>
+          </a:p>
+        </p:txBody>
+      </p:sp>
+      <p:sp>
+        <p:nvSpPr>
+          <p:cNvPr id="24" name="Shape 22"/>
+          <p:cNvSpPr/>
+          <p:nvPr/>
+        </p:nvSpPr>
+        <p:spPr>
+          <a:xfrm>
+            <a:off x="4407408" y="4608576"/>
+            <a:ext cx="91440" cy="91440"/>
+          </a:xfrm>
+          <a:prstGeom prst="ellipse">
+            <a:avLst/>
+          </a:prstGeom>
+          <a:solidFill>
+            <a:srgbClr val="A83787"/>
+          </a:solidFill>
+          <a:ln w="12700">
+            <a:solidFill>
+              <a:srgbClr val="A83787"/>
+            </a:solidFill>
+            <a:prstDash val="solid"/>
+          </a:ln>
+        </p:spPr>
+      </p:sp>
+      <p:sp>
+        <p:nvSpPr>
+          <p:cNvPr id="25" name="Text 23"/>
+          <p:cNvSpPr txBox="1"/>
+          <p:nvPr/>
+        </p:nvSpPr>
+        <p:spPr>
+          <a:xfrm>
+            <a:off x="4590288" y="4480560"/>
+            <a:ext cx="3246120" cy="502920"/>
+          </a:xfrm>
+          <a:prstGeom prst="rect">
+            <a:avLst/>
+          </a:prstGeom>
+          <a:noFill/>
+          <a:ln/>
+        </p:spPr>
+        <p:txBody>
+          <a:bodyPr wrap="square" lIns="0" tIns="0" rIns="0" bIns="0" rtlCol="0" anchor="t"/>
+          <a:lstStyle/>
+          <a:p>
+            <a:pPr indent="0" marL="0">
+              <a:buNone/>
+            </a:pPr>
+            <a:r>
+              <a:rPr lang="en-US" sz="1100" dirty="0">
+                <a:solidFill>
+                  <a:srgbClr val="3D3247"/>
+                </a:solidFill>
+                <a:latin typeface="Calibri" pitchFamily="34" charset="0"/>
+                <a:ea typeface="Calibri" pitchFamily="34" charset="-122"/>
+                <a:cs typeface="Calibri" pitchFamily="34" charset="-120"/>
+              </a:rPr>
+              <a:t>[Previous role / company — to add]</a:t>
+            </a:r>
+            <a:endParaRPr lang="en-US" sz="1100" dirty="0"/>
+          </a:p>
+        </p:txBody>
+      </p:sp>
+      <p:sp>
+        <p:nvSpPr>
+          <p:cNvPr id="26" name="Shape 24"/>
+          <p:cNvSpPr/>
+          <p:nvPr/>
+        </p:nvSpPr>
+        <p:spPr>
+          <a:xfrm>
+            <a:off x="4407408" y="5111496"/>
+            <a:ext cx="91440" cy="91440"/>
+          </a:xfrm>
+          <a:prstGeom prst="ellipse">
+            <a:avLst/>
+          </a:prstGeom>
+          <a:solidFill>
+            <a:srgbClr val="A83787"/>
+          </a:solidFill>
+          <a:ln w="12700">
+            <a:solidFill>
+              <a:srgbClr val="A83787"/>
+            </a:solidFill>
+            <a:prstDash val="solid"/>
+          </a:ln>
+        </p:spPr>
+      </p:sp>
+      <p:sp>
+        <p:nvSpPr>
+          <p:cNvPr id="27" name="Text 25"/>
+          <p:cNvSpPr txBox="1"/>
+          <p:nvPr/>
+        </p:nvSpPr>
+        <p:spPr>
+          <a:xfrm>
+            <a:off x="4590288" y="4983480"/>
+            <a:ext cx="3246120" cy="502920"/>
+          </a:xfrm>
+          <a:prstGeom prst="rect">
+            <a:avLst/>
+          </a:prstGeom>
+          <a:noFill/>
+          <a:ln/>
+        </p:spPr>
+        <p:txBody>
+          <a:bodyPr wrap="square" lIns="0" tIns="0" rIns="0" bIns="0" rtlCol="0" anchor="t"/>
+          <a:lstStyle/>
+          <a:p>
+            <a:pPr indent="0" marL="0">
+              <a:buNone/>
+            </a:pPr>
+            <a:r>
+              <a:rPr lang="en-US" sz="1100" dirty="0">
+                <a:solidFill>
+                  <a:srgbClr val="3D3247"/>
+                </a:solidFill>
+                <a:latin typeface="Calibri" pitchFamily="34" charset="0"/>
+                <a:ea typeface="Calibri" pitchFamily="34" charset="-122"/>
+                <a:cs typeface="Calibri" pitchFamily="34" charset="-120"/>
+              </a:rPr>
+              <a:t>[Education — to add]</a:t>
+            </a:r>
+            <a:endParaRPr lang="en-US" sz="1100" dirty="0"/>
+          </a:p>
+        </p:txBody>
+      </p:sp>
+      <p:sp>
+        <p:nvSpPr>
+          <p:cNvPr id="28" name="Shape 26"/>
+          <p:cNvSpPr/>
+          <p:nvPr/>
+        </p:nvSpPr>
+        <p:spPr>
+          <a:xfrm>
+            <a:off x="4407408" y="5614416"/>
+            <a:ext cx="91440" cy="91440"/>
+          </a:xfrm>
+          <a:prstGeom prst="ellipse">
+            <a:avLst/>
+          </a:prstGeom>
+          <a:solidFill>
+            <a:srgbClr val="A83787"/>
+          </a:solidFill>
+          <a:ln w="12700">
+            <a:solidFill>
+              <a:srgbClr val="A83787"/>
+            </a:solidFill>
+            <a:prstDash val="solid"/>
+          </a:ln>
+        </p:spPr>
+      </p:sp>
+      <p:sp>
+        <p:nvSpPr>
+          <p:cNvPr id="29" name="Text 27"/>
+          <p:cNvSpPr txBox="1"/>
+          <p:nvPr/>
+        </p:nvSpPr>
+        <p:spPr>
+          <a:xfrm>
+            <a:off x="4590288" y="5486400"/>
+            <a:ext cx="3246120" cy="502920"/>
+          </a:xfrm>
+          <a:prstGeom prst="rect">
+            <a:avLst/>
+          </a:prstGeom>
+          <a:noFill/>
+          <a:ln/>
+        </p:spPr>
+        <p:txBody>
+          <a:bodyPr wrap="square" lIns="0" tIns="0" rIns="0" bIns="0" rtlCol="0" anchor="t"/>
+          <a:lstStyle/>
+          <a:p>
+            <a:pPr indent="0" marL="0">
+              <a:buNone/>
+            </a:pPr>
+            <a:r>
+              <a:rPr lang="en-US" sz="1100" dirty="0">
+                <a:solidFill>
+                  <a:srgbClr val="3D3247"/>
+                </a:solidFill>
+                <a:latin typeface="Calibri" pitchFamily="34" charset="0"/>
+                <a:ea typeface="Calibri" pitchFamily="34" charset="-122"/>
+                <a:cs typeface="Calibri" pitchFamily="34" charset="-120"/>
+              </a:rPr>
+              <a:t>[Core skills or credentials — to add]</a:t>
+            </a:r>
+            <a:endParaRPr lang="en-US" sz="1100" dirty="0"/>
+          </a:p>
+        </p:txBody>
+      </p:sp>
+      <p:sp>
+        <p:nvSpPr>
+          <p:cNvPr id="30" name="Shape 28"/>
+          <p:cNvSpPr/>
+          <p:nvPr/>
+        </p:nvSpPr>
+        <p:spPr>
+          <a:xfrm>
+            <a:off x="9386316" y="1691640"/>
+            <a:ext cx="960120" cy="960120"/>
           </a:xfrm>
           <a:prstGeom prst="ellipse">
             <a:avLst/>
@@ -4735,14 +5275,14 @@
       </p:sp>
       <p:sp>
         <p:nvSpPr>
-          <p:cNvPr id="15" name="Text 13"/>
-          <p:cNvSpPr txBox="1"/>
-          <p:nvPr/>
-        </p:nvSpPr>
-        <p:spPr>
-          <a:xfrm>
-            <a:off x="9226296" y="2103120"/>
-            <a:ext cx="1280160" cy="1280160"/>
+          <p:cNvPr id="31" name="Text 29"/>
+          <p:cNvSpPr txBox="1"/>
+          <p:nvPr/>
+        </p:nvSpPr>
+        <p:spPr>
+          <a:xfrm>
+            <a:off x="9386316" y="1691640"/>
+            <a:ext cx="960120" cy="960120"/>
           </a:xfrm>
           <a:prstGeom prst="rect">
             <a:avLst/>
@@ -4758,7 +5298,7 @@
               <a:buNone/>
             </a:pPr>
             <a:r>
-              <a:rPr lang="en-US" sz="6000" dirty="0">
+              <a:rPr lang="en-US" sz="4400" dirty="0">
                 <a:solidFill>
                   <a:srgbClr val="FFFFFF"/>
                 </a:solidFill>
@@ -4768,20 +5308,20 @@
               </a:rPr>
               <a:t>D</a:t>
             </a:r>
-            <a:endParaRPr lang="en-US" sz="6000" dirty="0"/>
-          </a:p>
-        </p:txBody>
-      </p:sp>
-      <p:sp>
-        <p:nvSpPr>
-          <p:cNvPr id="16" name="Text 14"/>
-          <p:cNvSpPr txBox="1"/>
-          <p:nvPr/>
-        </p:nvSpPr>
-        <p:spPr>
-          <a:xfrm>
-            <a:off x="8083296" y="3566160"/>
-            <a:ext cx="3566160" cy="457200"/>
+            <a:endParaRPr lang="en-US" sz="4400" dirty="0"/>
+          </a:p>
+        </p:txBody>
+      </p:sp>
+      <p:sp>
+        <p:nvSpPr>
+          <p:cNvPr id="32" name="Text 30"/>
+          <p:cNvSpPr txBox="1"/>
+          <p:nvPr/>
+        </p:nvSpPr>
+        <p:spPr>
+          <a:xfrm>
+            <a:off x="8083296" y="2788920"/>
+            <a:ext cx="3566160" cy="411480"/>
           </a:xfrm>
           <a:prstGeom prst="rect">
             <a:avLst/>
@@ -4813,13 +5353,13 @@
       </p:sp>
       <p:sp>
         <p:nvSpPr>
-          <p:cNvPr id="17" name="Text 15"/>
-          <p:cNvSpPr txBox="1"/>
-          <p:nvPr/>
-        </p:nvSpPr>
-        <p:spPr>
-          <a:xfrm>
-            <a:off x="8083296" y="4023360"/>
+          <p:cNvPr id="33" name="Text 31"/>
+          <p:cNvSpPr txBox="1"/>
+          <p:nvPr/>
+        </p:nvSpPr>
+        <p:spPr>
+          <a:xfrm>
+            <a:off x="8083296" y="3182112"/>
             <a:ext cx="3566160" cy="274320"/>
           </a:xfrm>
           <a:prstGeom prst="rect">
@@ -4836,7 +5376,46 @@
               <a:buNone/>
             </a:pPr>
             <a:r>
-              <a:rPr lang="en-US" sz="1000" b="1" spc="400" kern="0" dirty="0">
+              <a:rPr lang="en-US" sz="1300" i="1" dirty="0">
+                <a:solidFill>
+                  <a:srgbClr val="8D82A0"/>
+                </a:solidFill>
+                <a:latin typeface="Cambria" pitchFamily="34" charset="0"/>
+                <a:ea typeface="Cambria" pitchFamily="34" charset="-122"/>
+                <a:cs typeface="Cambria" pitchFamily="34" charset="-120"/>
+              </a:rPr>
+              <a:t>Co-Founder</a:t>
+            </a:r>
+            <a:endParaRPr lang="en-US" sz="1300" dirty="0"/>
+          </a:p>
+        </p:txBody>
+      </p:sp>
+      <p:sp>
+        <p:nvSpPr>
+          <p:cNvPr id="34" name="Text 32"/>
+          <p:cNvSpPr txBox="1"/>
+          <p:nvPr/>
+        </p:nvSpPr>
+        <p:spPr>
+          <a:xfrm>
+            <a:off x="8174736" y="3520440"/>
+            <a:ext cx="3383280" cy="320040"/>
+          </a:xfrm>
+          <a:prstGeom prst="rect">
+            <a:avLst/>
+          </a:prstGeom>
+          <a:noFill/>
+          <a:ln/>
+        </p:spPr>
+        <p:txBody>
+          <a:bodyPr wrap="square" lIns="0" tIns="0" rIns="0" bIns="0" rtlCol="0" anchor="ctr"/>
+          <a:lstStyle/>
+          <a:p>
+            <a:pPr algn="ctr" indent="0" marL="0">
+              <a:buNone/>
+            </a:pPr>
+            <a:r>
+              <a:rPr lang="en-US" sz="1100" b="1" dirty="0">
                 <a:solidFill>
                   <a:srgbClr val="A83787"/>
                 </a:solidFill>
@@ -4844,137 +5423,368 @@
                 <a:ea typeface="Calibri" pitchFamily="34" charset="-122"/>
                 <a:cs typeface="Calibri" pitchFamily="34" charset="-120"/>
               </a:rPr>
-              <a:t>GTM &amp; SALES</a:t>
-            </a:r>
-            <a:endParaRPr lang="en-US" sz="1000" dirty="0"/>
-          </a:p>
-        </p:txBody>
-      </p:sp>
-      <p:sp>
-        <p:nvSpPr>
-          <p:cNvPr id="18" name="Text 16"/>
-          <p:cNvSpPr txBox="1"/>
-          <p:nvPr/>
-        </p:nvSpPr>
-        <p:spPr>
-          <a:xfrm>
-            <a:off x="8174736" y="4434840"/>
-            <a:ext cx="3383280" cy="1463040"/>
-          </a:xfrm>
-          <a:prstGeom prst="rect">
-            <a:avLst/>
-          </a:prstGeom>
-          <a:noFill/>
-          <a:ln/>
-        </p:spPr>
-        <p:txBody>
-          <a:bodyPr wrap="square" lIns="0" tIns="0" rIns="0" bIns="0" rtlCol="0" anchor="t"/>
-          <a:lstStyle/>
-          <a:p>
+              <a:t>Owns: </a:t>
+            </a:r>
             <a:pPr algn="ctr" indent="0" marL="0">
               <a:buNone/>
             </a:pPr>
             <a:r>
-              <a:rPr lang="en-US" sz="1200" dirty="0">
-                <a:solidFill>
-                  <a:srgbClr val="3D3247"/>
+              <a:rPr lang="en-US" sz="1100" dirty="0">
+                <a:solidFill>
+                  <a:srgbClr val="1F0F2A"/>
                 </a:solidFill>
                 <a:latin typeface="Calibri" pitchFamily="34" charset="0"/>
                 <a:ea typeface="Calibri" pitchFamily="34" charset="-122"/>
                 <a:cs typeface="Calibri" pitchFamily="34" charset="-120"/>
               </a:rPr>
-              <a:t>Owns institutional sales and pilots. In active conversation with The Wall Street School, Imarticus, and Vidya Mandir Classes for the first cohort.</a:t>
-            </a:r>
-            <a:endParaRPr lang="en-US" sz="1200" dirty="0"/>
-          </a:p>
-        </p:txBody>
-      </p:sp>
-      <p:sp>
-        <p:nvSpPr>
-          <p:cNvPr id="19" name="Text 17"/>
-          <p:cNvSpPr txBox="1"/>
-          <p:nvPr/>
-        </p:nvSpPr>
-        <p:spPr>
-          <a:xfrm>
-            <a:off x="548640" y="5897880"/>
-            <a:ext cx="11091672" cy="365760"/>
-          </a:xfrm>
-          <a:prstGeom prst="rect">
-            <a:avLst/>
-          </a:prstGeom>
-          <a:noFill/>
-          <a:ln/>
-        </p:spPr>
-        <p:txBody>
-          <a:bodyPr wrap="square" lIns="0" tIns="0" rIns="0" bIns="0" rtlCol="0" anchor="ctr"/>
-          <a:lstStyle/>
-          <a:p>
-            <a:pPr algn="ctr" indent="0" marL="0">
-              <a:buNone/>
-            </a:pPr>
-            <a:r>
-              <a:rPr lang="en-US" sz="1200" b="1" spc="300" kern="0" dirty="0">
-                <a:solidFill>
-                  <a:srgbClr val="8D82A0"/>
+              <a:t>GTM · Sales · Partnerships</a:t>
+            </a:r>
+            <a:endParaRPr lang="en-US" sz="1100" dirty="0"/>
+          </a:p>
+        </p:txBody>
+      </p:sp>
+      <p:sp>
+        <p:nvSpPr>
+          <p:cNvPr id="35" name="Shape 33"/>
+          <p:cNvSpPr/>
+          <p:nvPr/>
+        </p:nvSpPr>
+        <p:spPr>
+          <a:xfrm>
+            <a:off x="8174736" y="4105656"/>
+            <a:ext cx="91440" cy="91440"/>
+          </a:xfrm>
+          <a:prstGeom prst="ellipse">
+            <a:avLst/>
+          </a:prstGeom>
+          <a:solidFill>
+            <a:srgbClr val="A83787"/>
+          </a:solidFill>
+          <a:ln w="12700">
+            <a:solidFill>
+              <a:srgbClr val="A83787"/>
+            </a:solidFill>
+            <a:prstDash val="solid"/>
+          </a:ln>
+        </p:spPr>
+      </p:sp>
+      <p:sp>
+        <p:nvSpPr>
+          <p:cNvPr id="36" name="Text 34"/>
+          <p:cNvSpPr txBox="1"/>
+          <p:nvPr/>
+        </p:nvSpPr>
+        <p:spPr>
+          <a:xfrm>
+            <a:off x="8357616" y="3977640"/>
+            <a:ext cx="3246120" cy="502920"/>
+          </a:xfrm>
+          <a:prstGeom prst="rect">
+            <a:avLst/>
+          </a:prstGeom>
+          <a:noFill/>
+          <a:ln/>
+        </p:spPr>
+        <p:txBody>
+          <a:bodyPr wrap="square" lIns="0" tIns="0" rIns="0" bIns="0" rtlCol="0" anchor="t"/>
+          <a:lstStyle/>
+          <a:p>
+            <a:pPr indent="0" marL="0">
+              <a:buNone/>
+            </a:pPr>
+            <a:r>
+              <a:rPr lang="en-US" sz="1100" dirty="0">
+                <a:solidFill>
+                  <a:srgbClr val="3D3247"/>
                 </a:solidFill>
                 <a:latin typeface="Calibri" pitchFamily="34" charset="0"/>
                 <a:ea typeface="Calibri" pitchFamily="34" charset="-122"/>
                 <a:cs typeface="Calibri" pitchFamily="34" charset="-120"/>
               </a:rPr>
-              <a:t>CONTACT   </a:t>
-            </a:r>
-            <a:pPr algn="ctr" indent="0" marL="0">
-              <a:buNone/>
-            </a:pPr>
-            <a:r>
-              <a:rPr lang="en-US" sz="1200" b="1" dirty="0">
-                <a:solidFill>
-                  <a:srgbClr val="1F0F2A"/>
+              <a:t>20+ yrs leading data and automation solutions</a:t>
+            </a:r>
+            <a:endParaRPr lang="en-US" sz="1100" dirty="0"/>
+          </a:p>
+        </p:txBody>
+      </p:sp>
+      <p:sp>
+        <p:nvSpPr>
+          <p:cNvPr id="37" name="Shape 35"/>
+          <p:cNvSpPr/>
+          <p:nvPr/>
+        </p:nvSpPr>
+        <p:spPr>
+          <a:xfrm>
+            <a:off x="8174736" y="4608576"/>
+            <a:ext cx="91440" cy="91440"/>
+          </a:xfrm>
+          <a:prstGeom prst="ellipse">
+            <a:avLst/>
+          </a:prstGeom>
+          <a:solidFill>
+            <a:srgbClr val="A83787"/>
+          </a:solidFill>
+          <a:ln w="12700">
+            <a:solidFill>
+              <a:srgbClr val="A83787"/>
+            </a:solidFill>
+            <a:prstDash val="solid"/>
+          </a:ln>
+        </p:spPr>
+      </p:sp>
+      <p:sp>
+        <p:nvSpPr>
+          <p:cNvPr id="38" name="Text 36"/>
+          <p:cNvSpPr txBox="1"/>
+          <p:nvPr/>
+        </p:nvSpPr>
+        <p:spPr>
+          <a:xfrm>
+            <a:off x="8357616" y="4480560"/>
+            <a:ext cx="3246120" cy="502920"/>
+          </a:xfrm>
+          <a:prstGeom prst="rect">
+            <a:avLst/>
+          </a:prstGeom>
+          <a:noFill/>
+          <a:ln/>
+        </p:spPr>
+        <p:txBody>
+          <a:bodyPr wrap="square" lIns="0" tIns="0" rIns="0" bIns="0" rtlCol="0" anchor="t"/>
+          <a:lstStyle/>
+          <a:p>
+            <a:pPr indent="0" marL="0">
+              <a:buNone/>
+            </a:pPr>
+            <a:r>
+              <a:rPr lang="en-US" sz="1100" dirty="0">
+                <a:solidFill>
+                  <a:srgbClr val="3D3247"/>
                 </a:solidFill>
                 <a:latin typeface="Calibri" pitchFamily="34" charset="0"/>
                 <a:ea typeface="Calibri" pitchFamily="34" charset="-122"/>
                 <a:cs typeface="Calibri" pitchFamily="34" charset="-120"/>
               </a:rPr>
-              <a:t>Deepak Nagpal   ·   +91 XXXXX XXXXX   ·   contact@gyansaar.com</a:t>
-            </a:r>
-            <a:endParaRPr lang="en-US" sz="1200" dirty="0"/>
-          </a:p>
-        </p:txBody>
-      </p:sp>
-      <p:sp>
-        <p:nvSpPr>
-          <p:cNvPr id="20" name="Text 18"/>
-          <p:cNvSpPr txBox="1"/>
-          <p:nvPr/>
-        </p:nvSpPr>
-        <p:spPr>
-          <a:xfrm>
-            <a:off x="548640" y="6446520"/>
-            <a:ext cx="2743200" cy="274320"/>
-          </a:xfrm>
-          <a:prstGeom prst="rect">
-            <a:avLst/>
-          </a:prstGeom>
-          <a:noFill/>
-          <a:ln/>
-        </p:spPr>
-        <p:txBody>
-          <a:bodyPr wrap="square" lIns="0" tIns="0" rIns="0" bIns="0" rtlCol="0" anchor="ctr"/>
-          <a:lstStyle/>
-          <a:p>
-            <a:pPr indent="0" marL="0">
-              <a:buNone/>
-            </a:pPr>
-            <a:r>
-              <a:rPr lang="en-US" sz="900" b="1" spc="400" kern="0" dirty="0">
-                <a:solidFill>
-                  <a:srgbClr val="8D82A0"/>
+              <a:t>Ex-McKinsey · Ex-PwC</a:t>
+            </a:r>
+            <a:endParaRPr lang="en-US" sz="1100" dirty="0"/>
+          </a:p>
+        </p:txBody>
+      </p:sp>
+      <p:sp>
+        <p:nvSpPr>
+          <p:cNvPr id="39" name="Shape 37"/>
+          <p:cNvSpPr/>
+          <p:nvPr/>
+        </p:nvSpPr>
+        <p:spPr>
+          <a:xfrm>
+            <a:off x="8174736" y="5111496"/>
+            <a:ext cx="91440" cy="91440"/>
+          </a:xfrm>
+          <a:prstGeom prst="ellipse">
+            <a:avLst/>
+          </a:prstGeom>
+          <a:solidFill>
+            <a:srgbClr val="A83787"/>
+          </a:solidFill>
+          <a:ln w="12700">
+            <a:solidFill>
+              <a:srgbClr val="A83787"/>
+            </a:solidFill>
+            <a:prstDash val="solid"/>
+          </a:ln>
+        </p:spPr>
+      </p:sp>
+      <p:sp>
+        <p:nvSpPr>
+          <p:cNvPr id="40" name="Text 38"/>
+          <p:cNvSpPr txBox="1"/>
+          <p:nvPr/>
+        </p:nvSpPr>
+        <p:spPr>
+          <a:xfrm>
+            <a:off x="8357616" y="4983480"/>
+            <a:ext cx="3246120" cy="502920"/>
+          </a:xfrm>
+          <a:prstGeom prst="rect">
+            <a:avLst/>
+          </a:prstGeom>
+          <a:noFill/>
+          <a:ln/>
+        </p:spPr>
+        <p:txBody>
+          <a:bodyPr wrap="square" lIns="0" tIns="0" rIns="0" bIns="0" rtlCol="0" anchor="t"/>
+          <a:lstStyle/>
+          <a:p>
+            <a:pPr indent="0" marL="0">
+              <a:buNone/>
+            </a:pPr>
+            <a:r>
+              <a:rPr lang="en-US" sz="1100" dirty="0">
+                <a:solidFill>
+                  <a:srgbClr val="3D3247"/>
                 </a:solidFill>
                 <a:latin typeface="Calibri" pitchFamily="34" charset="0"/>
                 <a:ea typeface="Calibri" pitchFamily="34" charset="-122"/>
                 <a:cs typeface="Calibri" pitchFamily="34" charset="-120"/>
               </a:rPr>
+              <a:t>Currently Professor of Analytics &amp; AI at a reputed MBA college</a:t>
+            </a:r>
+            <a:endParaRPr lang="en-US" sz="1100" dirty="0"/>
+          </a:p>
+        </p:txBody>
+      </p:sp>
+      <p:sp>
+        <p:nvSpPr>
+          <p:cNvPr id="41" name="Shape 39"/>
+          <p:cNvSpPr/>
+          <p:nvPr/>
+        </p:nvSpPr>
+        <p:spPr>
+          <a:xfrm>
+            <a:off x="8174736" y="5614416"/>
+            <a:ext cx="91440" cy="91440"/>
+          </a:xfrm>
+          <a:prstGeom prst="ellipse">
+            <a:avLst/>
+          </a:prstGeom>
+          <a:solidFill>
+            <a:srgbClr val="A83787"/>
+          </a:solidFill>
+          <a:ln w="12700">
+            <a:solidFill>
+              <a:srgbClr val="A83787"/>
+            </a:solidFill>
+            <a:prstDash val="solid"/>
+          </a:ln>
+        </p:spPr>
+      </p:sp>
+      <p:sp>
+        <p:nvSpPr>
+          <p:cNvPr id="42" name="Text 40"/>
+          <p:cNvSpPr txBox="1"/>
+          <p:nvPr/>
+        </p:nvSpPr>
+        <p:spPr>
+          <a:xfrm>
+            <a:off x="8357616" y="5486400"/>
+            <a:ext cx="3246120" cy="502920"/>
+          </a:xfrm>
+          <a:prstGeom prst="rect">
+            <a:avLst/>
+          </a:prstGeom>
+          <a:noFill/>
+          <a:ln/>
+        </p:spPr>
+        <p:txBody>
+          <a:bodyPr wrap="square" lIns="0" tIns="0" rIns="0" bIns="0" rtlCol="0" anchor="t"/>
+          <a:lstStyle/>
+          <a:p>
+            <a:pPr indent="0" marL="0">
+              <a:buNone/>
+            </a:pPr>
+            <a:r>
+              <a:rPr lang="en-US" sz="1100" dirty="0">
+                <a:solidFill>
+                  <a:srgbClr val="3D3247"/>
+                </a:solidFill>
+                <a:latin typeface="Calibri" pitchFamily="34" charset="0"/>
+                <a:ea typeface="Calibri" pitchFamily="34" charset="-122"/>
+                <a:cs typeface="Calibri" pitchFamily="34" charset="-120"/>
+              </a:rPr>
+              <a:t>Deep education-sector experience</a:t>
+            </a:r>
+            <a:endParaRPr lang="en-US" sz="1100" dirty="0"/>
+          </a:p>
+        </p:txBody>
+      </p:sp>
+      <p:sp>
+        <p:nvSpPr>
+          <p:cNvPr id="43" name="Text 41"/>
+          <p:cNvSpPr txBox="1"/>
+          <p:nvPr/>
+        </p:nvSpPr>
+        <p:spPr>
+          <a:xfrm>
+            <a:off x="548640" y="6080760"/>
+            <a:ext cx="11091672" cy="320040"/>
+          </a:xfrm>
+          <a:prstGeom prst="rect">
+            <a:avLst/>
+          </a:prstGeom>
+          <a:noFill/>
+          <a:ln/>
+        </p:spPr>
+        <p:txBody>
+          <a:bodyPr wrap="square" lIns="0" tIns="0" rIns="0" bIns="0" rtlCol="0" anchor="ctr"/>
+          <a:lstStyle/>
+          <a:p>
+            <a:pPr algn="ctr" indent="0" marL="0">
+              <a:buNone/>
+            </a:pPr>
+            <a:r>
+              <a:rPr lang="en-US" sz="1200" b="1" spc="300" kern="0" dirty="0">
+                <a:solidFill>
+                  <a:srgbClr val="8D82A0"/>
+                </a:solidFill>
+                <a:latin typeface="Calibri" pitchFamily="34" charset="0"/>
+                <a:ea typeface="Calibri" pitchFamily="34" charset="-122"/>
+                <a:cs typeface="Calibri" pitchFamily="34" charset="-120"/>
+              </a:rPr>
+              <a:t>CONTACT   </a:t>
+            </a:r>
+            <a:pPr algn="ctr" indent="0" marL="0">
+              <a:buNone/>
+            </a:pPr>
+            <a:r>
+              <a:rPr lang="en-US" sz="1200" b="1" dirty="0">
+                <a:solidFill>
+                  <a:srgbClr val="1F0F2A"/>
+                </a:solidFill>
+                <a:latin typeface="Calibri" pitchFamily="34" charset="0"/>
+                <a:ea typeface="Calibri" pitchFamily="34" charset="-122"/>
+                <a:cs typeface="Calibri" pitchFamily="34" charset="-120"/>
+              </a:rPr>
+              <a:t>Deepak Nagpal   ·   +91 XXXXX XXXXX   ·   contact@gyansaar.com</a:t>
+            </a:r>
+            <a:endParaRPr lang="en-US" sz="1200" dirty="0"/>
+          </a:p>
+        </p:txBody>
+      </p:sp>
+      <p:sp>
+        <p:nvSpPr>
+          <p:cNvPr id="44" name="Text 42"/>
+          <p:cNvSpPr txBox="1"/>
+          <p:nvPr/>
+        </p:nvSpPr>
+        <p:spPr>
+          <a:xfrm>
+            <a:off x="548640" y="6446520"/>
+            <a:ext cx="2743200" cy="274320"/>
+          </a:xfrm>
+          <a:prstGeom prst="rect">
+            <a:avLst/>
+          </a:prstGeom>
+          <a:noFill/>
+          <a:ln/>
+        </p:spPr>
+        <p:txBody>
+          <a:bodyPr wrap="square" lIns="0" tIns="0" rIns="0" bIns="0" rtlCol="0" anchor="ctr"/>
+          <a:lstStyle/>
+          <a:p>
+            <a:pPr indent="0" marL="0">
+              <a:buNone/>
+            </a:pPr>
+            <a:r>
+              <a:rPr lang="en-US" sz="900" b="1" spc="400" kern="0" dirty="0">
+                <a:solidFill>
+                  <a:srgbClr val="8D82A0"/>
+                </a:solidFill>
+                <a:latin typeface="Calibri" pitchFamily="34" charset="0"/>
+                <a:ea typeface="Calibri" pitchFamily="34" charset="-122"/>
+                <a:cs typeface="Calibri" pitchFamily="34" charset="-120"/>
+              </a:rPr>
               <a:t>GYANSAAR</a:t>
             </a:r>
             <a:endParaRPr lang="en-US" sz="900" dirty="0"/>
@@ -4983,7 +5793,7 @@
       </p:sp>
       <p:sp>
         <p:nvSpPr>
-          <p:cNvPr id="21" name="Text 19"/>
+          <p:cNvPr id="45" name="Text 43"/>
           <p:cNvSpPr txBox="1"/>
           <p:nvPr/>
         </p:nvSpPr>

</xml_diff>